<commit_message>
Presentations: add YM to my deck throughout; update team deck sources and links
</commit_message>
<xml_diff>
--- a/Team_Results_presentation.pptx
+++ b/Team_Results_presentation.pptx
@@ -2225,7 +2225,7 @@
                 <a:ea typeface="Calibri" pitchFamily="34" charset="-122"/>
                 <a:cs typeface="Calibri" pitchFamily="34" charset="-120"/>
               </a:rPr>
-              <a:t>Sources: Reza/notebooks/08 (sections 9–10) · combined/surprise_dtw_book · combined/team_book</a:t>
+              <a:t>Sources: notebooks 08 and 08b (sections 9–10) · combined/surprise_dtw_book · combined/team_book</a:t>
             </a:r>
             <a:endParaRPr lang="en-US" sz="1500" dirty="0"/>
           </a:p>
@@ -2255,6 +2255,10 @@
             <a:prstDash val="solid"/>
           </a:ln>
         </p:spPr>
+        <p:txBody>
+          <a:bodyPr/>
+          <a:p/>
+        </p:txBody>
       </p:sp>
     </p:spTree>
   </p:cSld>
@@ -14936,7 +14940,7 @@
                 <a:ea typeface="Calibri" pitchFamily="34" charset="-122"/>
                 <a:cs typeface="Calibri" pitchFamily="34" charset="-120"/>
               </a:rPr>
-              <a:t>Code and results: github.com/jack-duncan/blackrock-intraday  ·  combined/ and Reza/</a:t>
+              <a:t>Team code and results: github.com/jack-duncan/blackrock-intraday  ·  Reza's study and papers: github.com/rezazamani2329/BlackRock-Project-State-Dependent-Intraday-Response-of-S-P-500-Futures-to-Macroeconomic-Surprises</a:t>
             </a:r>
             <a:endParaRPr lang="en-US" sz="1300" dirty="0"/>
           </a:p>

</xml_diff>